<commit_message>
Update three decks for the rename and the release steps
The project deck and the two federated use case decks name the dagents
package and how it is released. Their PDF exports and resources.json
were made again with scripts/export_presentations.py.

Co-Authored-By: Claude Opus 5.5 <noreply@anthropic.com>
Claude-Session: https://claude.ai/code/session_01CkvW9jztEMJsZMBJtMbrF9
</commit_message>
<xml_diff>
--- a/docs/presentation/healthcare-case-study/federated-healthcare-use-case/dagents-federated-healthcare-use-case.pptx
+++ b/docs/presentation/healthcare-case-study/federated-healthcare-use-case/dagents-federated-healthcare-use-case.pptx
@@ -2373,7 +2373,7 @@
           </a:p>
           <a:p>
             <a:r>
-              <a:t>- /Users/pradyundevarakonda/Developer/Dagents/agents/lma/README.md</a:t>
+              <a:t>- /Users/pradyundevarakonda/Developer/Dagents/dagents/lma/README.md</a:t>
             </a:r>
           </a:p>
           <a:p>
@@ -2478,7 +2478,7 @@
           </a:p>
           <a:p>
             <a:r>
-              <a:t>- /Users/pradyundevarakonda/Developer/Dagents/agents/gma/README.md</a:t>
+              <a:t>- /Users/pradyundevarakonda/Developer/Dagents/dagents/gma/README.md</a:t>
             </a:r>
           </a:p>
           <a:p>

</xml_diff>